<commit_message>
Build student screens, admin AI settings, and shared UI components
Wire frontend to the backend API, add auth context and role guards,
new UI/layout/message/AI components, and docs updates.

Co-Authored-By: Claude Opus 5.5 <noreply@anthropic.com>
</commit_message>
<xml_diff>
--- a/Doumentation/Presentaions/AI_Academic_Advisement_Sprint0.pptx
+++ b/Doumentation/Presentaions/AI_Academic_Advisement_Sprint0.pptx
@@ -135,8 +135,8 @@
 <pc:chgInfo xmlns:a="http://schemas.openxmlformats.org/drawingml/2006/main" xmlns:r="http://schemas.openxmlformats.org/officeDocument/2006/relationships" xmlns:ac="http://schemas.microsoft.com/office/drawing/2013/main/command" xmlns:pc="http://schemas.microsoft.com/office/powerpoint/2013/main/command">
   <pc:docChgLst>
     <pc:chgData name="Pranali Dukhande" userId="0ae46a4f0aa76adb" providerId="LiveId" clId="{DA6FBA60-F893-443A-AEE5-71C6A73E4BD7}"/>
-    <pc:docChg chg="custSel modSld">
-      <pc:chgData name="Pranali Dukhande" userId="0ae46a4f0aa76adb" providerId="LiveId" clId="{DA6FBA60-F893-443A-AEE5-71C6A73E4BD7}" dt="2026-09-22T03:55:24.939" v="19" actId="6549"/>
+    <pc:docChg chg="undo custSel modSld sldOrd">
+      <pc:chgData name="Pranali Dukhande" userId="0ae46a4f0aa76adb" providerId="LiveId" clId="{DA6FBA60-F893-443A-AEE5-71C6A73E4BD7}" dt="2026-09-30T00:33:15.641" v="34"/>
       <pc:docMkLst>
         <pc:docMk/>
       </pc:docMkLst>
@@ -146,14 +146,6 @@
           <pc:docMk/>
           <pc:sldMk cId="0" sldId="256"/>
         </pc:sldMkLst>
-        <pc:picChg chg="del">
-          <ac:chgData name="Pranali Dukhande" userId="0ae46a4f0aa76adb" providerId="LiveId" clId="{DA6FBA60-F893-443A-AEE5-71C6A73E4BD7}" dt="2026-09-22T03:54:28.745" v="1" actId="478"/>
-          <ac:picMkLst>
-            <pc:docMk/>
-            <pc:sldMk cId="0" sldId="256"/>
-            <ac:picMk id="20" creationId="{00000000-0000-0000-0000-000000000000}"/>
-          </ac:picMkLst>
-        </pc:picChg>
       </pc:sldChg>
       <pc:sldChg chg="delSp mod delAnim">
         <pc:chgData name="Pranali Dukhande" userId="0ae46a4f0aa76adb" providerId="LiveId" clId="{DA6FBA60-F893-443A-AEE5-71C6A73E4BD7}" dt="2026-09-22T03:54:35.182" v="2" actId="478"/>
@@ -161,29 +153,21 @@
           <pc:docMk/>
           <pc:sldMk cId="0" sldId="257"/>
         </pc:sldMkLst>
-        <pc:picChg chg="del">
-          <ac:chgData name="Pranali Dukhande" userId="0ae46a4f0aa76adb" providerId="LiveId" clId="{DA6FBA60-F893-443A-AEE5-71C6A73E4BD7}" dt="2026-09-22T03:54:35.182" v="2" actId="478"/>
-          <ac:picMkLst>
-            <pc:docMk/>
-            <pc:sldMk cId="0" sldId="257"/>
-            <ac:picMk id="41" creationId="{00000000-0000-0000-0000-000000000000}"/>
-          </ac:picMkLst>
-        </pc:picChg>
       </pc:sldChg>
-      <pc:sldChg chg="delSp mod delAnim">
-        <pc:chgData name="Pranali Dukhande" userId="0ae46a4f0aa76adb" providerId="LiveId" clId="{DA6FBA60-F893-443A-AEE5-71C6A73E4BD7}" dt="2026-09-22T03:54:41.050" v="3" actId="478"/>
+      <pc:sldChg chg="delSp modSp mod delAnim">
+        <pc:chgData name="Pranali Dukhande" userId="0ae46a4f0aa76adb" providerId="LiveId" clId="{DA6FBA60-F893-443A-AEE5-71C6A73E4BD7}" dt="2026-09-29T22:28:13.588" v="27" actId="20577"/>
         <pc:sldMkLst>
           <pc:docMk/>
           <pc:sldMk cId="0" sldId="258"/>
         </pc:sldMkLst>
-        <pc:picChg chg="del">
-          <ac:chgData name="Pranali Dukhande" userId="0ae46a4f0aa76adb" providerId="LiveId" clId="{DA6FBA60-F893-443A-AEE5-71C6A73E4BD7}" dt="2026-09-22T03:54:41.050" v="3" actId="478"/>
-          <ac:picMkLst>
+        <pc:spChg chg="mod">
+          <ac:chgData name="Pranali Dukhande" userId="0ae46a4f0aa76adb" providerId="LiveId" clId="{DA6FBA60-F893-443A-AEE5-71C6A73E4BD7}" dt="2026-09-29T22:28:13.588" v="27" actId="20577"/>
+          <ac:spMkLst>
             <pc:docMk/>
             <pc:sldMk cId="0" sldId="258"/>
-            <ac:picMk id="47" creationId="{00000000-0000-0000-0000-000000000000}"/>
-          </ac:picMkLst>
-        </pc:picChg>
+            <ac:spMk id="33" creationId="{00000000-0000-0000-0000-000000000000}"/>
+          </ac:spMkLst>
+        </pc:spChg>
       </pc:sldChg>
       <pc:sldChg chg="delSp mod delAnim">
         <pc:chgData name="Pranali Dukhande" userId="0ae46a4f0aa76adb" providerId="LiveId" clId="{DA6FBA60-F893-443A-AEE5-71C6A73E4BD7}" dt="2026-09-22T03:54:43.389" v="4" actId="478"/>
@@ -191,14 +175,6 @@
           <pc:docMk/>
           <pc:sldMk cId="0" sldId="259"/>
         </pc:sldMkLst>
-        <pc:picChg chg="del">
-          <ac:chgData name="Pranali Dukhande" userId="0ae46a4f0aa76adb" providerId="LiveId" clId="{DA6FBA60-F893-443A-AEE5-71C6A73E4BD7}" dt="2026-09-22T03:54:43.389" v="4" actId="478"/>
-          <ac:picMkLst>
-            <pc:docMk/>
-            <pc:sldMk cId="0" sldId="259"/>
-            <ac:picMk id="23" creationId="{00000000-0000-0000-0000-000000000000}"/>
-          </ac:picMkLst>
-        </pc:picChg>
       </pc:sldChg>
       <pc:sldChg chg="delSp mod delAnim">
         <pc:chgData name="Pranali Dukhande" userId="0ae46a4f0aa76adb" providerId="LiveId" clId="{DA6FBA60-F893-443A-AEE5-71C6A73E4BD7}" dt="2026-09-22T03:54:45.397" v="5" actId="478"/>
@@ -206,57 +182,49 @@
           <pc:docMk/>
           <pc:sldMk cId="0" sldId="260"/>
         </pc:sldMkLst>
-        <pc:picChg chg="del">
-          <ac:chgData name="Pranali Dukhande" userId="0ae46a4f0aa76adb" providerId="LiveId" clId="{DA6FBA60-F893-443A-AEE5-71C6A73E4BD7}" dt="2026-09-22T03:54:45.397" v="5" actId="478"/>
-          <ac:picMkLst>
-            <pc:docMk/>
-            <pc:sldMk cId="0" sldId="260"/>
-            <ac:picMk id="54" creationId="{00000000-0000-0000-0000-000000000000}"/>
-          </ac:picMkLst>
-        </pc:picChg>
       </pc:sldChg>
-      <pc:sldChg chg="delSp mod delAnim">
-        <pc:chgData name="Pranali Dukhande" userId="0ae46a4f0aa76adb" providerId="LiveId" clId="{DA6FBA60-F893-443A-AEE5-71C6A73E4BD7}" dt="2026-09-22T03:54:47.177" v="6" actId="478"/>
+      <pc:sldChg chg="delSp modSp mod delAnim">
+        <pc:chgData name="Pranali Dukhande" userId="0ae46a4f0aa76adb" providerId="LiveId" clId="{DA6FBA60-F893-443A-AEE5-71C6A73E4BD7}" dt="2026-09-29T22:29:10.862" v="32" actId="14100"/>
         <pc:sldMkLst>
           <pc:docMk/>
           <pc:sldMk cId="0" sldId="261"/>
         </pc:sldMkLst>
-        <pc:picChg chg="del">
-          <ac:chgData name="Pranali Dukhande" userId="0ae46a4f0aa76adb" providerId="LiveId" clId="{DA6FBA60-F893-443A-AEE5-71C6A73E4BD7}" dt="2026-09-22T03:54:47.177" v="6" actId="478"/>
+        <pc:picChg chg="mod modCrop">
+          <ac:chgData name="Pranali Dukhande" userId="0ae46a4f0aa76adb" providerId="LiveId" clId="{DA6FBA60-F893-443A-AEE5-71C6A73E4BD7}" dt="2026-09-29T22:29:10.862" v="32" actId="14100"/>
           <ac:picMkLst>
             <pc:docMk/>
             <pc:sldMk cId="0" sldId="261"/>
-            <ac:picMk id="100" creationId="{00000000-0000-0000-0000-000000000000}"/>
+            <ac:picMk id="4" creationId="{00000000-0000-0000-0000-000000000000}"/>
           </ac:picMkLst>
         </pc:picChg>
       </pc:sldChg>
-      <pc:sldChg chg="delSp mod delAnim">
-        <pc:chgData name="Pranali Dukhande" userId="0ae46a4f0aa76adb" providerId="LiveId" clId="{DA6FBA60-F893-443A-AEE5-71C6A73E4BD7}" dt="2026-09-22T03:54:49.190" v="7" actId="478"/>
+      <pc:sldChg chg="delSp modSp mod delAnim">
+        <pc:chgData name="Pranali Dukhande" userId="0ae46a4f0aa76adb" providerId="LiveId" clId="{DA6FBA60-F893-443A-AEE5-71C6A73E4BD7}" dt="2026-09-29T22:28:49.379" v="30" actId="14100"/>
         <pc:sldMkLst>
           <pc:docMk/>
           <pc:sldMk cId="0" sldId="262"/>
         </pc:sldMkLst>
-        <pc:picChg chg="del">
-          <ac:chgData name="Pranali Dukhande" userId="0ae46a4f0aa76adb" providerId="LiveId" clId="{DA6FBA60-F893-443A-AEE5-71C6A73E4BD7}" dt="2026-09-22T03:54:49.190" v="7" actId="478"/>
+        <pc:picChg chg="mod modCrop">
+          <ac:chgData name="Pranali Dukhande" userId="0ae46a4f0aa76adb" providerId="LiveId" clId="{DA6FBA60-F893-443A-AEE5-71C6A73E4BD7}" dt="2026-09-29T22:28:49.379" v="30" actId="14100"/>
           <ac:picMkLst>
             <pc:docMk/>
             <pc:sldMk cId="0" sldId="262"/>
-            <ac:picMk id="44" creationId="{00000000-0000-0000-0000-000000000000}"/>
+            <ac:picMk id="4" creationId="{00000000-0000-0000-0000-000000000000}"/>
           </ac:picMkLst>
         </pc:picChg>
       </pc:sldChg>
-      <pc:sldChg chg="delSp mod delAnim">
-        <pc:chgData name="Pranali Dukhande" userId="0ae46a4f0aa76adb" providerId="LiveId" clId="{DA6FBA60-F893-443A-AEE5-71C6A73E4BD7}" dt="2026-09-22T03:54:50.927" v="8" actId="478"/>
+      <pc:sldChg chg="delSp modSp mod delAnim">
+        <pc:chgData name="Pranali Dukhande" userId="0ae46a4f0aa76adb" providerId="LiveId" clId="{DA6FBA60-F893-443A-AEE5-71C6A73E4BD7}" dt="2026-09-29T22:10:02.793" v="21" actId="14100"/>
         <pc:sldMkLst>
           <pc:docMk/>
           <pc:sldMk cId="0" sldId="263"/>
         </pc:sldMkLst>
-        <pc:picChg chg="del">
-          <ac:chgData name="Pranali Dukhande" userId="0ae46a4f0aa76adb" providerId="LiveId" clId="{DA6FBA60-F893-443A-AEE5-71C6A73E4BD7}" dt="2026-09-22T03:54:50.927" v="8" actId="478"/>
+        <pc:picChg chg="mod modCrop">
+          <ac:chgData name="Pranali Dukhande" userId="0ae46a4f0aa76adb" providerId="LiveId" clId="{DA6FBA60-F893-443A-AEE5-71C6A73E4BD7}" dt="2026-09-29T22:10:02.793" v="21" actId="14100"/>
           <ac:picMkLst>
             <pc:docMk/>
             <pc:sldMk cId="0" sldId="263"/>
-            <ac:picMk id="27" creationId="{00000000-0000-0000-0000-000000000000}"/>
+            <ac:picMk id="4" creationId="{00000000-0000-0000-0000-000000000000}"/>
           </ac:picMkLst>
         </pc:picChg>
       </pc:sldChg>
@@ -266,14 +234,6 @@
           <pc:docMk/>
           <pc:sldMk cId="0" sldId="264"/>
         </pc:sldMkLst>
-        <pc:picChg chg="del">
-          <ac:chgData name="Pranali Dukhande" userId="0ae46a4f0aa76adb" providerId="LiveId" clId="{DA6FBA60-F893-443A-AEE5-71C6A73E4BD7}" dt="2026-09-22T03:54:53.238" v="9" actId="478"/>
-          <ac:picMkLst>
-            <pc:docMk/>
-            <pc:sldMk cId="0" sldId="264"/>
-            <ac:picMk id="62" creationId="{00000000-0000-0000-0000-000000000000}"/>
-          </ac:picMkLst>
-        </pc:picChg>
       </pc:sldChg>
       <pc:sldChg chg="delSp mod delAnim">
         <pc:chgData name="Pranali Dukhande" userId="0ae46a4f0aa76adb" providerId="LiveId" clId="{DA6FBA60-F893-443A-AEE5-71C6A73E4BD7}" dt="2026-09-22T03:54:56.291" v="10" actId="478"/>
@@ -281,14 +241,6 @@
           <pc:docMk/>
           <pc:sldMk cId="0" sldId="265"/>
         </pc:sldMkLst>
-        <pc:picChg chg="del">
-          <ac:chgData name="Pranali Dukhande" userId="0ae46a4f0aa76adb" providerId="LiveId" clId="{DA6FBA60-F893-443A-AEE5-71C6A73E4BD7}" dt="2026-09-22T03:54:56.291" v="10" actId="478"/>
-          <ac:picMkLst>
-            <pc:docMk/>
-            <pc:sldMk cId="0" sldId="265"/>
-            <ac:picMk id="44" creationId="{00000000-0000-0000-0000-000000000000}"/>
-          </ac:picMkLst>
-        </pc:picChg>
       </pc:sldChg>
       <pc:sldChg chg="delSp mod delAnim">
         <pc:chgData name="Pranali Dukhande" userId="0ae46a4f0aa76adb" providerId="LiveId" clId="{DA6FBA60-F893-443A-AEE5-71C6A73E4BD7}" dt="2026-09-22T03:55:00.192" v="11" actId="478"/>
@@ -296,14 +248,6 @@
           <pc:docMk/>
           <pc:sldMk cId="0" sldId="266"/>
         </pc:sldMkLst>
-        <pc:picChg chg="del">
-          <ac:chgData name="Pranali Dukhande" userId="0ae46a4f0aa76adb" providerId="LiveId" clId="{DA6FBA60-F893-443A-AEE5-71C6A73E4BD7}" dt="2026-09-22T03:55:00.192" v="11" actId="478"/>
-          <ac:picMkLst>
-            <pc:docMk/>
-            <pc:sldMk cId="0" sldId="266"/>
-            <ac:picMk id="47" creationId="{00000000-0000-0000-0000-000000000000}"/>
-          </ac:picMkLst>
-        </pc:picChg>
       </pc:sldChg>
       <pc:sldChg chg="delSp mod delAnim">
         <pc:chgData name="Pranali Dukhande" userId="0ae46a4f0aa76adb" providerId="LiveId" clId="{DA6FBA60-F893-443A-AEE5-71C6A73E4BD7}" dt="2026-09-22T03:55:02.199" v="12" actId="478"/>
@@ -311,14 +255,6 @@
           <pc:docMk/>
           <pc:sldMk cId="0" sldId="267"/>
         </pc:sldMkLst>
-        <pc:picChg chg="del">
-          <ac:chgData name="Pranali Dukhande" userId="0ae46a4f0aa76adb" providerId="LiveId" clId="{DA6FBA60-F893-443A-AEE5-71C6A73E4BD7}" dt="2026-09-22T03:55:02.199" v="12" actId="478"/>
-          <ac:picMkLst>
-            <pc:docMk/>
-            <pc:sldMk cId="0" sldId="267"/>
-            <ac:picMk id="34" creationId="{00000000-0000-0000-0000-000000000000}"/>
-          </ac:picMkLst>
-        </pc:picChg>
       </pc:sldChg>
       <pc:sldChg chg="delSp mod delAnim">
         <pc:chgData name="Pranali Dukhande" userId="0ae46a4f0aa76adb" providerId="LiveId" clId="{DA6FBA60-F893-443A-AEE5-71C6A73E4BD7}" dt="2026-09-22T03:55:18.201" v="18" actId="478"/>
@@ -326,22 +262,6 @@
           <pc:docMk/>
           <pc:sldMk cId="0" sldId="268"/>
         </pc:sldMkLst>
-        <pc:picChg chg="del">
-          <ac:chgData name="Pranali Dukhande" userId="0ae46a4f0aa76adb" providerId="LiveId" clId="{DA6FBA60-F893-443A-AEE5-71C6A73E4BD7}" dt="2026-09-22T03:55:04.738" v="13" actId="478"/>
-          <ac:picMkLst>
-            <pc:docMk/>
-            <pc:sldMk cId="0" sldId="268"/>
-            <ac:picMk id="11" creationId="{00000000-0000-0000-0000-000000000000}"/>
-          </ac:picMkLst>
-        </pc:picChg>
-        <pc:picChg chg="del">
-          <ac:chgData name="Pranali Dukhande" userId="0ae46a4f0aa76adb" providerId="LiveId" clId="{DA6FBA60-F893-443A-AEE5-71C6A73E4BD7}" dt="2026-09-22T03:55:18.201" v="18" actId="478"/>
-          <ac:picMkLst>
-            <pc:docMk/>
-            <pc:sldMk cId="0" sldId="268"/>
-            <ac:picMk id="21" creationId="{00000000-0000-0000-0000-000000000000}"/>
-          </ac:picMkLst>
-        </pc:picChg>
       </pc:sldChg>
       <pc:sldChg chg="delSp mod delAnim">
         <pc:chgData name="Pranali Dukhande" userId="0ae46a4f0aa76adb" providerId="LiveId" clId="{DA6FBA60-F893-443A-AEE5-71C6A73E4BD7}" dt="2026-09-22T03:55:10.849" v="15" actId="478"/>
@@ -349,22 +269,6 @@
           <pc:docMk/>
           <pc:sldMk cId="0" sldId="269"/>
         </pc:sldMkLst>
-        <pc:picChg chg="del">
-          <ac:chgData name="Pranali Dukhande" userId="0ae46a4f0aa76adb" providerId="LiveId" clId="{DA6FBA60-F893-443A-AEE5-71C6A73E4BD7}" dt="2026-09-22T03:55:07.771" v="14" actId="478"/>
-          <ac:picMkLst>
-            <pc:docMk/>
-            <pc:sldMk cId="0" sldId="269"/>
-            <ac:picMk id="13" creationId="{00000000-0000-0000-0000-000000000000}"/>
-          </ac:picMkLst>
-        </pc:picChg>
-        <pc:picChg chg="del">
-          <ac:chgData name="Pranali Dukhande" userId="0ae46a4f0aa76adb" providerId="LiveId" clId="{DA6FBA60-F893-443A-AEE5-71C6A73E4BD7}" dt="2026-09-22T03:55:10.849" v="15" actId="478"/>
-          <ac:picMkLst>
-            <pc:docMk/>
-            <pc:sldMk cId="0" sldId="269"/>
-            <ac:picMk id="21" creationId="{00000000-0000-0000-0000-000000000000}"/>
-          </ac:picMkLst>
-        </pc:picChg>
       </pc:sldChg>
       <pc:sldChg chg="delSp mod delAnim">
         <pc:chgData name="Pranali Dukhande" userId="0ae46a4f0aa76adb" providerId="LiveId" clId="{DA6FBA60-F893-443A-AEE5-71C6A73E4BD7}" dt="2026-09-22T03:55:14.069" v="17" actId="478"/>
@@ -372,14 +276,6 @@
           <pc:docMk/>
           <pc:sldMk cId="0" sldId="270"/>
         </pc:sldMkLst>
-        <pc:picChg chg="del">
-          <ac:chgData name="Pranali Dukhande" userId="0ae46a4f0aa76adb" providerId="LiveId" clId="{DA6FBA60-F893-443A-AEE5-71C6A73E4BD7}" dt="2026-09-22T03:55:14.069" v="17" actId="478"/>
-          <ac:picMkLst>
-            <pc:docMk/>
-            <pc:sldMk cId="0" sldId="270"/>
-            <ac:picMk id="9" creationId="{F384CBE9-3EAE-E7A6-61C3-ED5904DCBB15}"/>
-          </ac:picMkLst>
-        </pc:picChg>
       </pc:sldChg>
       <pc:sldChg chg="delSp mod delAnim">
         <pc:chgData name="Pranali Dukhande" userId="0ae46a4f0aa76adb" providerId="LiveId" clId="{DA6FBA60-F893-443A-AEE5-71C6A73E4BD7}" dt="2026-09-22T03:54:26.454" v="0" actId="478"/>
@@ -387,29 +283,13 @@
           <pc:docMk/>
           <pc:sldMk cId="0" sldId="271"/>
         </pc:sldMkLst>
-        <pc:picChg chg="del">
-          <ac:chgData name="Pranali Dukhande" userId="0ae46a4f0aa76adb" providerId="LiveId" clId="{DA6FBA60-F893-443A-AEE5-71C6A73E4BD7}" dt="2026-09-22T03:54:26.454" v="0" actId="478"/>
-          <ac:picMkLst>
-            <pc:docMk/>
-            <pc:sldMk cId="0" sldId="271"/>
-            <ac:picMk id="16" creationId="{00000000-0000-0000-0000-000000000000}"/>
-          </ac:picMkLst>
-        </pc:picChg>
       </pc:sldChg>
-      <pc:sldChg chg="delSp mod delAnim modNotesTx">
-        <pc:chgData name="Pranali Dukhande" userId="0ae46a4f0aa76adb" providerId="LiveId" clId="{DA6FBA60-F893-443A-AEE5-71C6A73E4BD7}" dt="2026-09-22T03:55:24.939" v="19" actId="6549"/>
+      <pc:sldChg chg="delSp mod ord delAnim modNotesTx">
+        <pc:chgData name="Pranali Dukhande" userId="0ae46a4f0aa76adb" providerId="LiveId" clId="{DA6FBA60-F893-443A-AEE5-71C6A73E4BD7}" dt="2026-09-30T00:33:15.641" v="34"/>
         <pc:sldMkLst>
           <pc:docMk/>
           <pc:sldMk cId="0" sldId="273"/>
         </pc:sldMkLst>
-        <pc:picChg chg="del">
-          <ac:chgData name="Pranali Dukhande" userId="0ae46a4f0aa76adb" providerId="LiveId" clId="{DA6FBA60-F893-443A-AEE5-71C6A73E4BD7}" dt="2026-09-22T03:55:12.387" v="16" actId="478"/>
-          <ac:picMkLst>
-            <pc:docMk/>
-            <pc:sldMk cId="0" sldId="273"/>
-            <ac:picMk id="66" creationId="{272890B6-7464-B0E6-4485-1A7C513CF8E2}"/>
-          </ac:picMkLst>
-        </pc:picChg>
       </pc:sldChg>
     </pc:docChg>
   </pc:docChgLst>
@@ -14126,14 +14006,14 @@
               <a:buNone/>
             </a:pPr>
             <a:r>
-              <a:rPr lang="en-US" sz="1150">
+              <a:rPr lang="en-US" sz="1150" dirty="0">
                 <a:solidFill>
                   <a:srgbClr val="66778C"/>
                 </a:solidFill>
               </a:rPr>
               <a:t>UI/UX Designer &amp; Documentation Lead</a:t>
             </a:r>
-            <a:endParaRPr lang="en-US" sz="1150"/>
+            <a:endParaRPr lang="en-US" sz="1150" dirty="0"/>
           </a:p>
         </p:txBody>
       </p:sp>
@@ -16530,7 +16410,7 @@
         </p:nvPicPr>
         <p:blipFill>
           <a:blip r:embed="rId3"/>
-          <a:srcRect t="1818" b="1818"/>
+          <a:srcRect t="1818" b="21479"/>
           <a:stretch>
             <a:fillRect/>
           </a:stretch>
@@ -16538,7 +16418,7 @@
         <p:spPr>
           <a:xfrm>
             <a:off x="594360" y="1170432"/>
-            <a:ext cx="3794760" cy="2148840"/>
+            <a:ext cx="3794760" cy="2011680"/>
           </a:xfrm>
           <a:prstGeom prst="rect">
             <a:avLst/>
@@ -17248,7 +17128,7 @@
         </p:nvPicPr>
         <p:blipFill>
           <a:blip r:embed="rId3"/>
-          <a:srcRect t="3308" b="3308"/>
+          <a:srcRect t="3308" b="19203"/>
           <a:stretch>
             <a:fillRect/>
           </a:stretch>
@@ -17256,7 +17136,7 @@
         <p:spPr>
           <a:xfrm>
             <a:off x="594360" y="1170432"/>
-            <a:ext cx="3794760" cy="2148840"/>
+            <a:ext cx="3794760" cy="2113542"/>
           </a:xfrm>
           <a:prstGeom prst="rect">
             <a:avLst/>
@@ -17966,7 +17846,7 @@
         </p:nvPicPr>
         <p:blipFill>
           <a:blip r:embed="rId3"/>
-          <a:srcRect t="1818" b="1818"/>
+          <a:srcRect t="1818" b="18220"/>
           <a:stretch>
             <a:fillRect/>
           </a:stretch>
@@ -17974,7 +17854,7 @@
         <p:spPr>
           <a:xfrm>
             <a:off x="594360" y="1170432"/>
-            <a:ext cx="3794760" cy="2148840"/>
+            <a:ext cx="3794760" cy="2039112"/>
           </a:xfrm>
           <a:prstGeom prst="rect">
             <a:avLst/>

</xml_diff>

<commit_message>
Add Sprint 1 documentation
Sprint 1 burndown chart, product backlog, presentation, wiki screenshots,
and updated Sprint 0 deck and team working agreement.
</commit_message>
<xml_diff>
--- a/Doumentation/Presentaions/AI_Academic_Advisement_Sprint0.pptx
+++ b/Doumentation/Presentaions/AI_Academic_Advisement_Sprint0.pptx
@@ -131,12 +131,20 @@
 </p:presentation>
 </file>
 
+<file path=ppt/revisionInfo.xml><?xml version="1.0" encoding="utf-8"?>
+<p1510:revInfo xmlns:a="http://schemas.openxmlformats.org/drawingml/2006/main" xmlns:r="http://schemas.openxmlformats.org/officeDocument/2006/relationships" xmlns:p1510="http://schemas.microsoft.com/office/powerpoint/2015/10/main">
+  <p1510:revLst>
+    <p1510:client id="{729CE56D-74F3-4E0A-B87B-B6543643B7B9}" v="8" dt="2026-10-18T22:17:42.612"/>
+  </p1510:revLst>
+</p1510:revInfo>
+</file>
+
 <file path=ppt/changesInfos/changesInfo1.xml><?xml version="1.0" encoding="utf-8"?>
 <pc:chgInfo xmlns:a="http://schemas.openxmlformats.org/drawingml/2006/main" xmlns:r="http://schemas.openxmlformats.org/officeDocument/2006/relationships" xmlns:ac="http://schemas.microsoft.com/office/drawing/2013/main/command" xmlns:pc="http://schemas.microsoft.com/office/powerpoint/2013/main/command">
   <pc:docChgLst>
     <pc:chgData name="Pranali Dukhande" userId="0ae46a4f0aa76adb" providerId="LiveId" clId="{DA6FBA60-F893-443A-AEE5-71C6A73E4BD7}"/>
     <pc:docChg chg="undo custSel modSld sldOrd">
-      <pc:chgData name="Pranali Dukhande" userId="0ae46a4f0aa76adb" providerId="LiveId" clId="{DA6FBA60-F893-443A-AEE5-71C6A73E4BD7}" dt="2026-09-30T00:33:15.641" v="34"/>
+      <pc:chgData name="Pranali Dukhande" userId="0ae46a4f0aa76adb" providerId="LiveId" clId="{DA6FBA60-F893-443A-AEE5-71C6A73E4BD7}" dt="2026-10-18T22:17:42.612" v="54" actId="767"/>
       <pc:docMkLst>
         <pc:docMk/>
       </pc:docMkLst>
@@ -176,12 +184,44 @@
           <pc:sldMk cId="0" sldId="259"/>
         </pc:sldMkLst>
       </pc:sldChg>
-      <pc:sldChg chg="delSp mod delAnim">
-        <pc:chgData name="Pranali Dukhande" userId="0ae46a4f0aa76adb" providerId="LiveId" clId="{DA6FBA60-F893-443A-AEE5-71C6A73E4BD7}" dt="2026-09-22T03:54:45.397" v="5" actId="478"/>
+      <pc:sldChg chg="addSp delSp modSp mod delAnim">
+        <pc:chgData name="Pranali Dukhande" userId="0ae46a4f0aa76adb" providerId="LiveId" clId="{DA6FBA60-F893-443A-AEE5-71C6A73E4BD7}" dt="2026-10-18T22:17:42.612" v="54" actId="767"/>
         <pc:sldMkLst>
           <pc:docMk/>
           <pc:sldMk cId="0" sldId="260"/>
         </pc:sldMkLst>
+        <pc:spChg chg="add del mod">
+          <ac:chgData name="Pranali Dukhande" userId="0ae46a4f0aa76adb" providerId="LiveId" clId="{DA6FBA60-F893-443A-AEE5-71C6A73E4BD7}" dt="2026-10-18T22:17:42.612" v="54" actId="767"/>
+          <ac:spMkLst>
+            <pc:docMk/>
+            <pc:sldMk cId="0" sldId="260"/>
+            <ac:spMk id="41" creationId="{44AE3E45-BA3A-615D-C82C-A0D8DE45F687}"/>
+          </ac:spMkLst>
+        </pc:spChg>
+        <pc:spChg chg="add mod">
+          <ac:chgData name="Pranali Dukhande" userId="0ae46a4f0aa76adb" providerId="LiveId" clId="{DA6FBA60-F893-443A-AEE5-71C6A73E4BD7}" dt="2026-10-18T22:17:41.310" v="52" actId="767"/>
+          <ac:spMkLst>
+            <pc:docMk/>
+            <pc:sldMk cId="0" sldId="260"/>
+            <ac:spMk id="42" creationId="{53CF4726-D606-A56D-074B-65175C822776}"/>
+          </ac:spMkLst>
+        </pc:spChg>
+        <pc:spChg chg="add del mod">
+          <ac:chgData name="Pranali Dukhande" userId="0ae46a4f0aa76adb" providerId="LiveId" clId="{DA6FBA60-F893-443A-AEE5-71C6A73E4BD7}" dt="2026-10-18T22:17:40.610" v="50" actId="767"/>
+          <ac:spMkLst>
+            <pc:docMk/>
+            <pc:sldMk cId="0" sldId="260"/>
+            <ac:spMk id="43" creationId="{72571B98-CE2D-21F9-7495-3D96112AD588}"/>
+          </ac:spMkLst>
+        </pc:spChg>
+        <pc:spChg chg="add del mod">
+          <ac:chgData name="Pranali Dukhande" userId="0ae46a4f0aa76adb" providerId="LiveId" clId="{DA6FBA60-F893-443A-AEE5-71C6A73E4BD7}" dt="2026-10-18T22:17:40.076" v="48" actId="767"/>
+          <ac:spMkLst>
+            <pc:docMk/>
+            <pc:sldMk cId="0" sldId="260"/>
+            <ac:spMk id="44" creationId="{B30EC316-1CBF-058A-45E0-7E72832FA95A}"/>
+          </ac:spMkLst>
+        </pc:spChg>
       </pc:sldChg>
       <pc:sldChg chg="delSp modSp mod delAnim">
         <pc:chgData name="Pranali Dukhande" userId="0ae46a4f0aa76adb" providerId="LiveId" clId="{DA6FBA60-F893-443A-AEE5-71C6A73E4BD7}" dt="2026-09-29T22:29:10.862" v="32" actId="14100"/>
@@ -214,13 +254,13 @@
         </pc:picChg>
       </pc:sldChg>
       <pc:sldChg chg="delSp modSp mod delAnim">
-        <pc:chgData name="Pranali Dukhande" userId="0ae46a4f0aa76adb" providerId="LiveId" clId="{DA6FBA60-F893-443A-AEE5-71C6A73E4BD7}" dt="2026-09-29T22:10:02.793" v="21" actId="14100"/>
+        <pc:chgData name="Pranali Dukhande" userId="0ae46a4f0aa76adb" providerId="LiveId" clId="{DA6FBA60-F893-443A-AEE5-71C6A73E4BD7}" dt="2026-10-18T22:06:35.083" v="36" actId="1076"/>
         <pc:sldMkLst>
           <pc:docMk/>
           <pc:sldMk cId="0" sldId="263"/>
         </pc:sldMkLst>
         <pc:picChg chg="mod modCrop">
-          <ac:chgData name="Pranali Dukhande" userId="0ae46a4f0aa76adb" providerId="LiveId" clId="{DA6FBA60-F893-443A-AEE5-71C6A73E4BD7}" dt="2026-09-29T22:10:02.793" v="21" actId="14100"/>
+          <ac:chgData name="Pranali Dukhande" userId="0ae46a4f0aa76adb" providerId="LiveId" clId="{DA6FBA60-F893-443A-AEE5-71C6A73E4BD7}" dt="2026-10-18T22:06:35.083" v="36" actId="1076"/>
           <ac:picMkLst>
             <pc:docMk/>
             <pc:sldMk cId="0" sldId="263"/>
@@ -249,12 +289,20 @@
           <pc:sldMk cId="0" sldId="266"/>
         </pc:sldMkLst>
       </pc:sldChg>
-      <pc:sldChg chg="delSp mod delAnim">
-        <pc:chgData name="Pranali Dukhande" userId="0ae46a4f0aa76adb" providerId="LiveId" clId="{DA6FBA60-F893-443A-AEE5-71C6A73E4BD7}" dt="2026-09-22T03:55:02.199" v="12" actId="478"/>
+      <pc:sldChg chg="delSp modSp mod delAnim">
+        <pc:chgData name="Pranali Dukhande" userId="0ae46a4f0aa76adb" providerId="LiveId" clId="{DA6FBA60-F893-443A-AEE5-71C6A73E4BD7}" dt="2026-10-18T21:53:22.769" v="35" actId="14100"/>
         <pc:sldMkLst>
           <pc:docMk/>
           <pc:sldMk cId="0" sldId="267"/>
         </pc:sldMkLst>
+        <pc:spChg chg="mod">
+          <ac:chgData name="Pranali Dukhande" userId="0ae46a4f0aa76adb" providerId="LiveId" clId="{DA6FBA60-F893-443A-AEE5-71C6A73E4BD7}" dt="2026-10-18T21:53:22.769" v="35" actId="14100"/>
+          <ac:spMkLst>
+            <pc:docMk/>
+            <pc:sldMk cId="0" sldId="267"/>
+            <ac:spMk id="19" creationId="{00000000-0000-0000-0000-000000000000}"/>
+          </ac:spMkLst>
+        </pc:spChg>
       </pc:sldChg>
       <pc:sldChg chg="delSp mod delAnim">
         <pc:chgData name="Pranali Dukhande" userId="0ae46a4f0aa76adb" providerId="LiveId" clId="{DA6FBA60-F893-443A-AEE5-71C6A73E4BD7}" dt="2026-09-22T03:55:18.201" v="18" actId="478"/>
@@ -2216,7 +2264,7 @@
           </a:prstGeom>
           <a:extLst>
             <a:ext uri="{C572A759-6A51-4108-AA02-DFA0A04FC94B}">
-              <ma14:wrappingTextBoxFlag xmlns="" xmlns:ma14="http://schemas.microsoft.com/office/mac/drawingml/2011/main" val="0"/>
+              <ma14:wrappingTextBoxFlag xmlns:ma14="http://schemas.microsoft.com/office/mac/drawingml/2011/main" xmlns="" val="0"/>
             </a:ext>
           </a:extLst>
         </p:spPr>
@@ -7432,8 +7480,8 @@
         </p:nvSpPr>
         <p:spPr>
           <a:xfrm>
-            <a:off x="1371600" y="3575304"/>
-            <a:ext cx="9784080" cy="914400"/>
+            <a:off x="1371600" y="3616868"/>
+            <a:ext cx="9784080" cy="831273"/>
           </a:xfrm>
           <a:prstGeom prst="roundRect">
             <a:avLst>
@@ -7489,14 +7537,14 @@
               <a:buNone/>
             </a:pPr>
             <a:r>
-              <a:rPr lang="en-US" sz="1500" b="1">
+              <a:rPr lang="en-US" sz="1500" b="1" dirty="0">
                 <a:solidFill>
                   <a:srgbClr val="5D46A8"/>
                 </a:solidFill>
               </a:rPr>
               <a:t>Sprint 2 — Intelligence &amp; Intervention</a:t>
             </a:r>
-            <a:endParaRPr lang="en-US" sz="1500"/>
+            <a:endParaRPr lang="en-US" sz="1500" dirty="0"/>
           </a:p>
         </p:txBody>
       </p:sp>
@@ -7736,14 +7784,14 @@
               <a:buNone/>
             </a:pPr>
             <a:r>
-              <a:rPr lang="en-US" sz="1250">
+              <a:rPr lang="en-US" sz="1250" dirty="0">
                 <a:solidFill>
                   <a:srgbClr val="1B2B42"/>
                 </a:solidFill>
               </a:rPr>
               <a:t>Conversational AI/RAG • testing • security • deployment</a:t>
             </a:r>
-            <a:endParaRPr lang="en-US" sz="1250"/>
+            <a:endParaRPr lang="en-US" sz="1250" dirty="0"/>
           </a:p>
         </p:txBody>
       </p:sp>
@@ -11230,7 +11278,7 @@
           </a:prstGeom>
           <a:extLst>
             <a:ext uri="{C572A759-6A51-4108-AA02-DFA0A04FC94B}">
-              <ma14:wrappingTextBoxFlag xmlns="" xmlns:ma14="http://schemas.microsoft.com/office/mac/drawingml/2011/main" val="0"/>
+              <ma14:wrappingTextBoxFlag xmlns:ma14="http://schemas.microsoft.com/office/mac/drawingml/2011/main" xmlns="" val="0"/>
             </a:ext>
           </a:extLst>
         </p:spPr>
@@ -17853,7 +17901,7 @@
         </p:blipFill>
         <p:spPr>
           <a:xfrm>
-            <a:off x="594360" y="1170432"/>
+            <a:off x="342900" y="992124"/>
             <a:ext cx="3794760" cy="2039112"/>
           </a:xfrm>
           <a:prstGeom prst="rect">
@@ -19046,12 +19094,9 @@
 </file>
 
 <file path=customXml/item1.xml><?xml version="1.0" encoding="utf-8"?>
-<?mso-contentType ?>
-<FormTemplates xmlns="http://schemas.microsoft.com/sharepoint/v3/contenttype/forms">
-  <Display>DocumentLibraryForm</Display>
-  <Edit>DocumentLibraryForm</Edit>
-  <New>DocumentLibraryForm</New>
-</FormTemplates>
+<p:properties xmlns:p="http://schemas.microsoft.com/office/2006/metadata/properties" xmlns:xsi="http://www.w3.org/2001/XMLSchema-instance" xmlns:pc="http://schemas.microsoft.com/office/infopath/2007/PartnerControls">
+  <documentManagement/>
+</p:properties>
 </file>
 
 <file path=customXml/item2.xml><?xml version="1.0" encoding="utf-8"?>
@@ -19181,13 +19226,16 @@
 </file>
 
 <file path=customXml/item3.xml><?xml version="1.0" encoding="utf-8"?>
-<p:properties xmlns:p="http://schemas.microsoft.com/office/2006/metadata/properties" xmlns:xsi="http://www.w3.org/2001/XMLSchema-instance" xmlns:pc="http://schemas.microsoft.com/office/infopath/2007/PartnerControls">
-  <documentManagement/>
-</p:properties>
+<?mso-contentType ?>
+<FormTemplates xmlns="http://schemas.microsoft.com/sharepoint/v3/contenttype/forms">
+  <Display>DocumentLibraryForm</Display>
+  <Edit>DocumentLibraryForm</Edit>
+  <New>DocumentLibraryForm</New>
+</FormTemplates>
 </file>
 
 <file path=customXml/itemProps1.xml><?xml version="1.0" encoding="utf-8"?>
-<ds:datastoreItem xmlns:ds="http://schemas.openxmlformats.org/officeDocument/2006/customXml" ds:itemID="{CA360DD2-9930-4FAB-B877-75E8D578753E}">
+<ds:datastoreItem xmlns:ds="http://schemas.openxmlformats.org/officeDocument/2006/customXml" ds:itemID="{08CDF36F-3D18-4671-BE55-2ADDB25900B7}">
   <ds:schemaRefs/>
 </ds:datastoreItem>
 </file>
@@ -19199,7 +19247,7 @@
 </file>
 
 <file path=customXml/itemProps3.xml><?xml version="1.0" encoding="utf-8"?>
-<ds:datastoreItem xmlns:ds="http://schemas.openxmlformats.org/officeDocument/2006/customXml" ds:itemID="{08CDF36F-3D18-4671-BE55-2ADDB25900B7}">
+<ds:datastoreItem xmlns:ds="http://schemas.openxmlformats.org/officeDocument/2006/customXml" ds:itemID="{CA360DD2-9930-4FAB-B877-75E8D578753E}">
   <ds:schemaRefs/>
 </ds:datastoreItem>
 </file>
</xml_diff>